<commit_message>
docs(release): 同步 v1.12.19 口径（后端 13,067 / 前端 6,409）与 PPT 数字
- README 质量指标与测试体系：后端 12,795→13,067（664 文件）、前端 6,363→6,409（303 文件）、
  覆盖率语句/分支 40546/9880→41503/10118、Alembic 47→50 版本、v1.12.18→v1.12.19
- CHANGELOG [1.12.19] 用例口径校正为实测值
- PPT 41 页同步：版本号 36 处、用例数、测试总数 19,476、测试文件 303、视图 132
- 收录 W18 深度探测证据（.scratch/w18-deep-probe/：数据完整性/离线运行探测脚本与结论）
</commit_message>
<xml_diff>
--- a/docs/帮扶管理信息系统介绍.pptx
+++ b/docs/帮扶管理信息系统介绍.pptx
@@ -4976,7 +4976,7 @@
                 <a:ea typeface="微软雅黑" pitchFamily="34" charset="-122"/>
                 <a:cs typeface="微软雅黑" pitchFamily="34" charset="-120"/>
               </a:rPr>
-              <a:t>V1.12.18  |  2026-10-17  |  FastAPI + Vue 3 + Electron + SQLite</a:t>
+              <a:t>V1.12.19  |  2026-10-17  |  FastAPI + Vue 3 + Electron + SQLite</a:t>
             </a:r>
             <a:endParaRPr lang="en-US" sz="1250" dirty="0"/>
           </a:p>
@@ -5196,7 +5196,7 @@
                 <a:ea typeface="微软雅黑" pitchFamily="34" charset="-122"/>
                 <a:cs typeface="微软雅黑" pitchFamily="34" charset="-120"/>
               </a:rPr>
-              <a:t>帮扶管理信息系统 v1.12.18</a:t>
+              <a:t>帮扶管理信息系统 v1.12.19</a:t>
             </a:r>
             <a:endParaRPr lang="en-US" sz="1050" dirty="0"/>
           </a:p>
@@ -5315,7 +5315,7 @@
                 <a:ea typeface="微软雅黑" pitchFamily="34" charset="-122"/>
                 <a:cs typeface="微软雅黑" pitchFamily="34" charset="-120"/>
               </a:rPr>
-              <a:t>131 个业务视图（34 个功能目录）</a:t>
+              <a:t>132 个业务视图（34 个功能目录）</a:t>
             </a:r>
             <a:endParaRPr lang="en-US" sz="1350" dirty="0"/>
           </a:p>
@@ -5378,7 +5378,7 @@
                 <a:ea typeface="微软雅黑" pitchFamily="34" charset="-122"/>
                 <a:cs typeface="微软雅黑" pitchFamily="34" charset="-120"/>
               </a:rPr>
-              <a:t>301 个测试文件 · 6363 个用例</a:t>
+              <a:t>303 个测试文件 · 6409 个用例</a:t>
             </a:r>
             <a:endParaRPr lang="en-US" sz="1350" dirty="0"/>
           </a:p>
@@ -5822,7 +5822,7 @@
                 <a:ea typeface="微软雅黑" pitchFamily="34" charset="-122"/>
                 <a:cs typeface="微软雅黑" pitchFamily="34" charset="-120"/>
               </a:rPr>
-              <a:t>帮扶管理信息系统 v1.12.18</a:t>
+              <a:t>帮扶管理信息系统 v1.12.19</a:t>
             </a:r>
             <a:endParaRPr lang="en-US" sz="1050" dirty="0"/>
           </a:p>
@@ -6754,7 +6754,7 @@
                 <a:ea typeface="微软雅黑" pitchFamily="34" charset="-122"/>
                 <a:cs typeface="微软雅黑" pitchFamily="34" charset="-120"/>
               </a:rPr>
-              <a:t>帮扶管理信息系统 v1.12.18</a:t>
+              <a:t>帮扶管理信息系统 v1.12.19</a:t>
             </a:r>
             <a:endParaRPr lang="en-US" sz="1050" dirty="0"/>
           </a:p>
@@ -7380,7 +7380,7 @@
                 <a:ea typeface="微软雅黑" pitchFamily="34" charset="-122"/>
                 <a:cs typeface="微软雅黑" pitchFamily="34" charset="-120"/>
               </a:rPr>
-              <a:t>帮扶管理信息系统 v1.12.18</a:t>
+              <a:t>帮扶管理信息系统 v1.12.19</a:t>
             </a:r>
             <a:endParaRPr lang="en-US" sz="1050" dirty="0"/>
           </a:p>
@@ -8809,7 +8809,7 @@
                 <a:ea typeface="微软雅黑" pitchFamily="34" charset="-122"/>
                 <a:cs typeface="微软雅黑" pitchFamily="34" charset="-120"/>
               </a:rPr>
-              <a:t>帮扶管理信息系统 v1.12.18</a:t>
+              <a:t>帮扶管理信息系统 v1.12.19</a:t>
             </a:r>
             <a:endParaRPr lang="en-US" sz="1050" dirty="0"/>
           </a:p>
@@ -10006,7 +10006,7 @@
                 <a:ea typeface="微软雅黑" pitchFamily="34" charset="-122"/>
                 <a:cs typeface="微软雅黑" pitchFamily="34" charset="-120"/>
               </a:rPr>
-              <a:t>帮扶管理信息系统 v1.12.18</a:t>
+              <a:t>帮扶管理信息系统 v1.12.19</a:t>
             </a:r>
             <a:endParaRPr lang="en-US" sz="1050" dirty="0"/>
           </a:p>
@@ -10632,7 +10632,7 @@
                 <a:ea typeface="微软雅黑" pitchFamily="34" charset="-122"/>
                 <a:cs typeface="微软雅黑" pitchFamily="34" charset="-120"/>
               </a:rPr>
-              <a:t>帮扶管理信息系统 v1.12.18</a:t>
+              <a:t>帮扶管理信息系统 v1.12.19</a:t>
             </a:r>
             <a:endParaRPr lang="en-US" sz="1050" dirty="0"/>
           </a:p>
@@ -11496,7 +11496,7 @@
                 <a:ea typeface="微软雅黑" pitchFamily="34" charset="-122"/>
                 <a:cs typeface="微软雅黑" pitchFamily="34" charset="-120"/>
               </a:rPr>
-              <a:t>帮扶管理信息系统 v1.12.18</a:t>
+              <a:t>帮扶管理信息系统 v1.12.19</a:t>
             </a:r>
             <a:endParaRPr lang="en-US" sz="1050" dirty="0"/>
           </a:p>
@@ -12235,7 +12235,7 @@
                 <a:ea typeface="微软雅黑" pitchFamily="34" charset="-122"/>
                 <a:cs typeface="微软雅黑" pitchFamily="34" charset="-120"/>
               </a:rPr>
-              <a:t>帮扶管理信息系统 v1.12.18</a:t>
+              <a:t>帮扶管理信息系统 v1.12.19</a:t>
             </a:r>
             <a:endParaRPr lang="en-US" sz="1050" dirty="0"/>
           </a:p>
@@ -14460,7 +14460,7 @@
                 <a:ea typeface="微软雅黑" pitchFamily="34" charset="-122"/>
                 <a:cs typeface="微软雅黑" pitchFamily="34" charset="-120"/>
               </a:rPr>
-              <a:t>18,745 项自动化测试 · CI/CD · 依赖自检</a:t>
+              <a:t>19,476 项自动化测试 · CI/CD · 依赖自检</a:t>
             </a:r>
             <a:endParaRPr lang="en-US" sz="1200" dirty="0"/>
           </a:p>
@@ -14829,7 +14829,7 @@
                 <a:ea typeface="微软雅黑" pitchFamily="34" charset="-122"/>
                 <a:cs typeface="微软雅黑" pitchFamily="34" charset="-120"/>
               </a:rPr>
-              <a:t>帮扶管理信息系统 v1.12.18</a:t>
+              <a:t>帮扶管理信息系统 v1.12.19</a:t>
             </a:r>
             <a:endParaRPr lang="en-US" sz="1050" dirty="0"/>
           </a:p>
@@ -15455,7 +15455,7 @@
                 <a:ea typeface="微软雅黑" pitchFamily="34" charset="-122"/>
                 <a:cs typeface="微软雅黑" pitchFamily="34" charset="-120"/>
               </a:rPr>
-              <a:t>帮扶管理信息系统 v1.12.18</a:t>
+              <a:t>帮扶管理信息系统 v1.12.19</a:t>
             </a:r>
             <a:endParaRPr lang="en-US" sz="1050" dirty="0"/>
           </a:p>
@@ -16150,7 +16150,7 @@
                 <a:ea typeface="微软雅黑" pitchFamily="34" charset="-122"/>
                 <a:cs typeface="微软雅黑" pitchFamily="34" charset="-120"/>
               </a:rPr>
-              <a:t>帮扶管理信息系统 v1.12.18</a:t>
+              <a:t>帮扶管理信息系统 v1.12.19</a:t>
             </a:r>
             <a:endParaRPr lang="en-US" sz="1050" dirty="0"/>
           </a:p>
@@ -16849,7 +16849,7 @@
                 <a:ea typeface="微软雅黑" pitchFamily="34" charset="-122"/>
                 <a:cs typeface="微软雅黑" pitchFamily="34" charset="-120"/>
               </a:rPr>
-              <a:t>帮扶管理信息系统 v1.12.18</a:t>
+              <a:t>帮扶管理信息系统 v1.12.19</a:t>
             </a:r>
             <a:endParaRPr lang="en-US" sz="1050" dirty="0"/>
           </a:p>
@@ -17759,7 +17759,7 @@
                 <a:ea typeface="微软雅黑" pitchFamily="34" charset="-122"/>
                 <a:cs typeface="微软雅黑" pitchFamily="34" charset="-120"/>
               </a:rPr>
-              <a:t>帮扶管理信息系统 v1.12.18</a:t>
+              <a:t>帮扶管理信息系统 v1.12.19</a:t>
             </a:r>
             <a:endParaRPr lang="en-US" sz="1050" dirty="0"/>
           </a:p>
@@ -18973,7 +18973,7 @@
                 <a:ea typeface="微软雅黑" pitchFamily="34" charset="-122"/>
                 <a:cs typeface="微软雅黑" pitchFamily="34" charset="-120"/>
               </a:rPr>
-              <a:t>帮扶管理信息系统 v1.12.18</a:t>
+              <a:t>帮扶管理信息系统 v1.12.19</a:t>
             </a:r>
             <a:endParaRPr lang="en-US" sz="1050" dirty="0"/>
           </a:p>
@@ -20008,7 +20008,7 @@
                 <a:ea typeface="微软雅黑" pitchFamily="34" charset="-122"/>
                 <a:cs typeface="微软雅黑" pitchFamily="34" charset="-120"/>
               </a:rPr>
-              <a:t>帮扶管理信息系统 v1.12.18</a:t>
+              <a:t>帮扶管理信息系统 v1.12.19</a:t>
             </a:r>
             <a:endParaRPr lang="en-US" sz="1050" dirty="0"/>
           </a:p>
@@ -20857,7 +20857,7 @@
                 <a:ea typeface="微软雅黑" pitchFamily="34" charset="-122"/>
                 <a:cs typeface="微软雅黑" pitchFamily="34" charset="-120"/>
               </a:rPr>
-              <a:t>帮扶管理信息系统 v1.12.18</a:t>
+              <a:t>帮扶管理信息系统 v1.12.19</a:t>
             </a:r>
             <a:endParaRPr lang="en-US" sz="1050" dirty="0"/>
           </a:p>
@@ -21771,7 +21771,7 @@
                 <a:ea typeface="微软雅黑" pitchFamily="34" charset="-122"/>
                 <a:cs typeface="微软雅黑" pitchFamily="34" charset="-120"/>
               </a:rPr>
-              <a:t>帮扶管理信息系统 v1.12.18</a:t>
+              <a:t>帮扶管理信息系统 v1.12.19</a:t>
             </a:r>
             <a:endParaRPr lang="en-US" sz="1050" dirty="0"/>
           </a:p>
@@ -22931,7 +22931,7 @@
                 <a:ea typeface="微软雅黑" pitchFamily="34" charset="-122"/>
                 <a:cs typeface="微软雅黑" pitchFamily="34" charset="-120"/>
               </a:rPr>
-              <a:t>帮扶管理信息系统 v1.12.18</a:t>
+              <a:t>帮扶管理信息系统 v1.12.19</a:t>
             </a:r>
             <a:endParaRPr lang="en-US" sz="1050" dirty="0"/>
           </a:p>
@@ -23585,7 +23585,7 @@
                 <a:ea typeface="微软雅黑" pitchFamily="34" charset="-122"/>
                 <a:cs typeface="微软雅黑" pitchFamily="34" charset="-120"/>
               </a:rPr>
-              <a:t>18,745 项自动化测试（后端 12795 + 前端 6363）</a:t>
+              <a:t>19,476 项自动化测试（后端 13067 + 前端 6409）</a:t>
             </a:r>
             <a:endParaRPr lang="en-US" sz="1400" dirty="0"/>
           </a:p>
@@ -23951,7 +23951,7 @@
                 <a:ea typeface="微软雅黑" pitchFamily="34" charset="-122"/>
                 <a:cs typeface="微软雅黑" pitchFamily="34" charset="-120"/>
               </a:rPr>
-              <a:t>帮扶管理信息系统 v1.12.18</a:t>
+              <a:t>帮扶管理信息系统 v1.12.19</a:t>
             </a:r>
             <a:endParaRPr lang="en-US" sz="1050" dirty="0"/>
           </a:p>
@@ -24008,7 +24008,7 @@
                 <a:ea typeface="微软雅黑" pitchFamily="34" charset="-122"/>
                 <a:cs typeface="微软雅黑" pitchFamily="34" charset="-120"/>
               </a:rPr>
-              <a:t>数据来源：2026-10-17 实测（v1.12.18）· 后端 12795 / 前端 6363 用例 · 覆盖率 100%（行+分支）</a:t>
+              <a:t>数据来源：2026-10-17 实测（v1.12.19）· 后端 13067 / 前端 6409 用例 · 覆盖率 100%（行+分支）</a:t>
             </a:r>
             <a:endParaRPr lang="en-US" sz="1050" dirty="0"/>
           </a:p>
@@ -24473,7 +24473,7 @@
                 <a:ea typeface="微软雅黑" pitchFamily="34" charset="-122"/>
                 <a:cs typeface="微软雅黑" pitchFamily="34" charset="-120"/>
               </a:rPr>
-              <a:t>帮扶管理信息系统 v1.12.18</a:t>
+              <a:t>帮扶管理信息系统 v1.12.19</a:t>
             </a:r>
             <a:endParaRPr lang="en-US" sz="1050" dirty="0"/>
           </a:p>
@@ -25166,7 +25166,7 @@
                 <a:ea typeface="微软雅黑" pitchFamily="34" charset="-122"/>
                 <a:cs typeface="微软雅黑" pitchFamily="34" charset="-120"/>
               </a:rPr>
-              <a:t>帮扶管理信息系统 v1.12.18</a:t>
+              <a:t>帮扶管理信息系统 v1.12.19</a:t>
             </a:r>
             <a:endParaRPr lang="en-US" sz="1050" dirty="0"/>
           </a:p>
@@ -25792,7 +25792,7 @@
                 <a:ea typeface="微软雅黑" pitchFamily="34" charset="-122"/>
                 <a:cs typeface="微软雅黑" pitchFamily="34" charset="-120"/>
               </a:rPr>
-              <a:t>帮扶管理信息系统 v1.12.18</a:t>
+              <a:t>帮扶管理信息系统 v1.12.19</a:t>
             </a:r>
             <a:endParaRPr lang="en-US" sz="1050" dirty="0"/>
           </a:p>
@@ -26743,7 +26743,7 @@
                 <a:ea typeface="微软雅黑" pitchFamily="34" charset="-122"/>
                 <a:cs typeface="微软雅黑" pitchFamily="34" charset="-120"/>
               </a:rPr>
-              <a:t>帮扶管理信息系统 v1.12.18</a:t>
+              <a:t>帮扶管理信息系统 v1.12.19</a:t>
             </a:r>
             <a:endParaRPr lang="en-US" sz="1050" dirty="0"/>
           </a:p>
@@ -27841,7 +27841,7 @@
                 <a:ea typeface="微软雅黑" pitchFamily="34" charset="-122"/>
                 <a:cs typeface="微软雅黑" pitchFamily="34" charset="-120"/>
               </a:rPr>
-              <a:t>帮扶管理信息系统 v1.12.18</a:t>
+              <a:t>帮扶管理信息系统 v1.12.19</a:t>
             </a:r>
             <a:endParaRPr lang="en-US" sz="1050" dirty="0"/>
           </a:p>
@@ -28488,7 +28488,7 @@
                 <a:ea typeface="微软雅黑" pitchFamily="34" charset="-122"/>
                 <a:cs typeface="微软雅黑" pitchFamily="34" charset="-120"/>
               </a:rPr>
-              <a:t>帮扶管理信息系统 v1.12.18</a:t>
+              <a:t>帮扶管理信息系统 v1.12.19</a:t>
             </a:r>
             <a:endParaRPr lang="en-US" sz="1050" dirty="0"/>
           </a:p>
@@ -29324,7 +29324,7 @@
                 <a:ea typeface="微软雅黑" pitchFamily="34" charset="-122"/>
                 <a:cs typeface="微软雅黑" pitchFamily="34" charset="-120"/>
               </a:rPr>
-              <a:t>净效果：12795 后端用例（行+分支覆盖率 100%）+ 6363 前端用例全绿；Windows x64 与麒麟 ARM64 两个离线安装包由 GitHub Actions 全自动构建并发布 Release</a:t>
+              <a:t>净效果：13067 后端用例（行+分支覆盖率 100%）+ 6409 前端用例全绿；Windows x64 与麒麟 ARM64 两个离线安装包由 GitHub Actions 全自动构建并发布 Release</a:t>
             </a:r>
             <a:endParaRPr lang="en-US" sz="1350" dirty="0"/>
           </a:p>
@@ -29544,7 +29544,7 @@
                 <a:ea typeface="微软雅黑" pitchFamily="34" charset="-122"/>
                 <a:cs typeface="微软雅黑" pitchFamily="34" charset="-120"/>
               </a:rPr>
-              <a:t>帮扶管理信息系统 v1.12.18</a:t>
+              <a:t>帮扶管理信息系统 v1.12.19</a:t>
             </a:r>
             <a:endParaRPr lang="en-US" sz="1050" dirty="0"/>
           </a:p>
@@ -30123,7 +30123,7 @@
                 <a:ea typeface="微软雅黑" pitchFamily="34" charset="-122"/>
                 <a:cs typeface="微软雅黑" pitchFamily="34" charset="-120"/>
               </a:rPr>
-              <a:t>帮扶管理信息系统 v1.12.18</a:t>
+              <a:t>帮扶管理信息系统 v1.12.19</a:t>
             </a:r>
             <a:endParaRPr lang="en-US" sz="1050" dirty="0"/>
           </a:p>
@@ -31016,7 +31016,7 @@
                 <a:ea typeface="微软雅黑" pitchFamily="34" charset="-122"/>
                 <a:cs typeface="微软雅黑" pitchFamily="34" charset="-120"/>
               </a:rPr>
-              <a:t>帮扶管理信息系统 v1.12.18  ·  仓库：github.com/lzh745200/MRRS  ·  完整文档见 docs/ 目录</a:t>
+              <a:t>帮扶管理信息系统 v1.12.19  ·  仓库：github.com/lzh745200/MRRS  ·  完整文档见 docs/ 目录</a:t>
             </a:r>
             <a:endParaRPr lang="en-US" sz="1350" dirty="0"/>
           </a:p>
@@ -31057,7 +31057,7 @@
                 <a:ea typeface="微软雅黑" pitchFamily="34" charset="-122"/>
                 <a:cs typeface="微软雅黑" pitchFamily="34" charset="-120"/>
               </a:rPr>
-              <a:t>12795 后端用例（行+分支覆盖率 100%）+ 6363 前端用例 全绿守护 · Windows x64 / 麒麟 ARM64 双平台离线交付</a:t>
+              <a:t>13067 后端用例（行+分支覆盖率 100%）+ 6409 前端用例 全绿守护 · Windows x64 / 麒麟 ARM64 双平台离线交付</a:t>
             </a:r>
             <a:endParaRPr lang="en-US" sz="1350" dirty="0"/>
           </a:p>
@@ -31277,7 +31277,7 @@
                 <a:ea typeface="微软雅黑" pitchFamily="34" charset="-122"/>
                 <a:cs typeface="微软雅黑" pitchFamily="34" charset="-120"/>
               </a:rPr>
-              <a:t>帮扶管理信息系统 v1.12.18</a:t>
+              <a:t>帮扶管理信息系统 v1.12.19</a:t>
             </a:r>
             <a:endParaRPr lang="en-US" sz="1050" dirty="0"/>
           </a:p>
@@ -32053,7 +32053,7 @@
                 <a:ea typeface="微软雅黑" pitchFamily="34" charset="-122"/>
                 <a:cs typeface="微软雅黑" pitchFamily="34" charset="-120"/>
               </a:rPr>
-              <a:t>帮扶管理信息系统 v1.12.18</a:t>
+              <a:t>帮扶管理信息系统 v1.12.19</a:t>
             </a:r>
             <a:endParaRPr lang="en-US" sz="1050" dirty="0"/>
           </a:p>
@@ -32094,7 +32094,7 @@
                 <a:ea typeface="微软雅黑" pitchFamily="34" charset="-122"/>
                 <a:cs typeface="微软雅黑" pitchFamily="34" charset="-120"/>
               </a:rPr>
-              <a:t>12795</a:t>
+              <a:t>13067</a:t>
             </a:r>
             <a:endParaRPr lang="en-US" sz="4000" dirty="0"/>
           </a:p>
@@ -32176,7 +32176,7 @@
                 <a:ea typeface="微软雅黑" pitchFamily="34" charset="-122"/>
                 <a:cs typeface="微软雅黑" pitchFamily="34" charset="-120"/>
               </a:rPr>
-              <a:t>6363</a:t>
+              <a:t>6409</a:t>
             </a:r>
             <a:endParaRPr lang="en-US" sz="4000" dirty="0"/>
           </a:p>
@@ -32340,7 +32340,7 @@
                 <a:ea typeface="微软雅黑" pitchFamily="34" charset="-122"/>
                 <a:cs typeface="微软雅黑" pitchFamily="34" charset="-120"/>
               </a:rPr>
-              <a:t>131</a:t>
+              <a:t>132</a:t>
             </a:r>
             <a:endParaRPr lang="en-US" sz="4000" dirty="0"/>
           </a:p>
@@ -32777,7 +32777,7 @@
                 <a:ea typeface="微软雅黑" pitchFamily="34" charset="-122"/>
                 <a:cs typeface="微软雅黑" pitchFamily="34" charset="-120"/>
               </a:rPr>
-              <a:t>数据来源：2026-10-17 仓库实测（v1.12.18）—— 后端 12795 用例全绿 / 行+分支覆盖率 100%（branch=True 严格门禁）· 前端 6363 用例全绿 · flake8 0 · bandit 0 中高危 · vue-tsc 0 · eslint 0 警告</a:t>
+              <a:t>数据来源：2026-10-17 仓库实测（v1.12.19）—— 后端 13067 用例全绿 / 行+分支覆盖率 100%（branch=True 严格门禁）· 前端 6409 用例全绿 · flake8 0 · bandit 0 中高危 · vue-tsc 0 · eslint 0 警告</a:t>
             </a:r>
             <a:endParaRPr lang="en-US" sz="1000" dirty="0"/>
           </a:p>
@@ -33301,7 +33301,7 @@
                 <a:ea typeface="微软雅黑" pitchFamily="34" charset="-122"/>
                 <a:cs typeface="微软雅黑" pitchFamily="34" charset="-120"/>
               </a:rPr>
-              <a:t>帮扶管理信息系统 v1.12.18</a:t>
+              <a:t>帮扶管理信息系统 v1.12.19</a:t>
             </a:r>
             <a:endParaRPr lang="en-US" sz="1050" dirty="0"/>
           </a:p>
@@ -33726,7 +33726,7 @@
                 <a:ea typeface="微软雅黑" pitchFamily="34" charset="-122"/>
                 <a:cs typeface="微软雅黑" pitchFamily="34" charset="-120"/>
               </a:rPr>
-              <a:t>131 个视图 · 25 个共享组件</a:t>
+              <a:t>132 个视图 · 25 个共享组件</a:t>
             </a:r>
             <a:endParaRPr lang="en-US" sz="1200" dirty="0"/>
           </a:p>
@@ -34413,7 +34413,7 @@
                 <a:ea typeface="微软雅黑" pitchFamily="34" charset="-122"/>
                 <a:cs typeface="微软雅黑" pitchFamily="34" charset="-120"/>
               </a:rPr>
-              <a:t>帮扶管理信息系统 v1.12.18</a:t>
+              <a:t>帮扶管理信息系统 v1.12.19</a:t>
             </a:r>
             <a:endParaRPr lang="en-US" sz="1050" dirty="0"/>
           </a:p>
@@ -34657,7 +34657,7 @@
                 <a:ea typeface="微软雅黑" pitchFamily="34" charset="-122"/>
                 <a:cs typeface="微软雅黑" pitchFamily="34" charset="-120"/>
               </a:rPr>
-              <a:t>131 视图 · Pinia · Axios 信封拦截器 · CSRF 续期 · 离线 Mock</a:t>
+              <a:t>132 视图 · Pinia · Axios 信封拦截器 · CSRF 续期 · 离线 Mock</a:t>
             </a:r>
             <a:endParaRPr lang="en-US" sz="1250" dirty="0"/>
           </a:p>

</xml_diff>

<commit_message>
chore(release): v1.12.20 — 安装器卸载口径修正（W19）
v1.12.19 的发布标签指向 629c285，不含安装器卸载修复（60f2a8e）。该缺陷会让卸载后
真实用户数据（数据库 / 密钥 / 日志）残留，必须以新版本发布修正产物。

- 版本 1.12.19 → 1.12.20（根 package.json 单源，sync-version 同步 15 文件）
- CHANGELOG 新增 [1.12.20]：应用功能与 v1.12.19 一致，仅安装器修复
- README 全量验证口径版本号更新
- PPT 版本号 1.12.20（41 页）

实机验证：安装后 /health 返回 version=1.12.20、git_hash 为本提交；注册表 UserDataPath
指向真实 userData（单反斜杠、路径存在）；静默卸载保留数据、程序目录清空。
</commit_message>
<xml_diff>
--- a/docs/帮扶管理信息系统介绍.pptx
+++ b/docs/帮扶管理信息系统介绍.pptx
@@ -4976,7 +4976,7 @@
                 <a:ea typeface="微软雅黑" pitchFamily="34" charset="-122"/>
                 <a:cs typeface="微软雅黑" pitchFamily="34" charset="-120"/>
               </a:rPr>
-              <a:t>V1.12.19  |  2026-10-17  |  FastAPI + Vue 3 + Electron + SQLite</a:t>
+              <a:t>V1.12.20  |  2026-10-17  |  FastAPI + Vue 3 + Electron + SQLite</a:t>
             </a:r>
             <a:endParaRPr lang="en-US" sz="1250" dirty="0"/>
           </a:p>
@@ -5196,7 +5196,7 @@
                 <a:ea typeface="微软雅黑" pitchFamily="34" charset="-122"/>
                 <a:cs typeface="微软雅黑" pitchFamily="34" charset="-120"/>
               </a:rPr>
-              <a:t>帮扶管理信息系统 v1.12.19</a:t>
+              <a:t>帮扶管理信息系统 v1.12.20</a:t>
             </a:r>
             <a:endParaRPr lang="en-US" sz="1050" dirty="0"/>
           </a:p>
@@ -5822,7 +5822,7 @@
                 <a:ea typeface="微软雅黑" pitchFamily="34" charset="-122"/>
                 <a:cs typeface="微软雅黑" pitchFamily="34" charset="-120"/>
               </a:rPr>
-              <a:t>帮扶管理信息系统 v1.12.19</a:t>
+              <a:t>帮扶管理信息系统 v1.12.20</a:t>
             </a:r>
             <a:endParaRPr lang="en-US" sz="1050" dirty="0"/>
           </a:p>
@@ -6754,7 +6754,7 @@
                 <a:ea typeface="微软雅黑" pitchFamily="34" charset="-122"/>
                 <a:cs typeface="微软雅黑" pitchFamily="34" charset="-120"/>
               </a:rPr>
-              <a:t>帮扶管理信息系统 v1.12.19</a:t>
+              <a:t>帮扶管理信息系统 v1.12.20</a:t>
             </a:r>
             <a:endParaRPr lang="en-US" sz="1050" dirty="0"/>
           </a:p>
@@ -7380,7 +7380,7 @@
                 <a:ea typeface="微软雅黑" pitchFamily="34" charset="-122"/>
                 <a:cs typeface="微软雅黑" pitchFamily="34" charset="-120"/>
               </a:rPr>
-              <a:t>帮扶管理信息系统 v1.12.19</a:t>
+              <a:t>帮扶管理信息系统 v1.12.20</a:t>
             </a:r>
             <a:endParaRPr lang="en-US" sz="1050" dirty="0"/>
           </a:p>
@@ -8809,7 +8809,7 @@
                 <a:ea typeface="微软雅黑" pitchFamily="34" charset="-122"/>
                 <a:cs typeface="微软雅黑" pitchFamily="34" charset="-120"/>
               </a:rPr>
-              <a:t>帮扶管理信息系统 v1.12.19</a:t>
+              <a:t>帮扶管理信息系统 v1.12.20</a:t>
             </a:r>
             <a:endParaRPr lang="en-US" sz="1050" dirty="0"/>
           </a:p>
@@ -10006,7 +10006,7 @@
                 <a:ea typeface="微软雅黑" pitchFamily="34" charset="-122"/>
                 <a:cs typeface="微软雅黑" pitchFamily="34" charset="-120"/>
               </a:rPr>
-              <a:t>帮扶管理信息系统 v1.12.19</a:t>
+              <a:t>帮扶管理信息系统 v1.12.20</a:t>
             </a:r>
             <a:endParaRPr lang="en-US" sz="1050" dirty="0"/>
           </a:p>
@@ -10632,7 +10632,7 @@
                 <a:ea typeface="微软雅黑" pitchFamily="34" charset="-122"/>
                 <a:cs typeface="微软雅黑" pitchFamily="34" charset="-120"/>
               </a:rPr>
-              <a:t>帮扶管理信息系统 v1.12.19</a:t>
+              <a:t>帮扶管理信息系统 v1.12.20</a:t>
             </a:r>
             <a:endParaRPr lang="en-US" sz="1050" dirty="0"/>
           </a:p>
@@ -11496,7 +11496,7 @@
                 <a:ea typeface="微软雅黑" pitchFamily="34" charset="-122"/>
                 <a:cs typeface="微软雅黑" pitchFamily="34" charset="-120"/>
               </a:rPr>
-              <a:t>帮扶管理信息系统 v1.12.19</a:t>
+              <a:t>帮扶管理信息系统 v1.12.20</a:t>
             </a:r>
             <a:endParaRPr lang="en-US" sz="1050" dirty="0"/>
           </a:p>
@@ -12235,7 +12235,7 @@
                 <a:ea typeface="微软雅黑" pitchFamily="34" charset="-122"/>
                 <a:cs typeface="微软雅黑" pitchFamily="34" charset="-120"/>
               </a:rPr>
-              <a:t>帮扶管理信息系统 v1.12.19</a:t>
+              <a:t>帮扶管理信息系统 v1.12.20</a:t>
             </a:r>
             <a:endParaRPr lang="en-US" sz="1050" dirty="0"/>
           </a:p>
@@ -14829,7 +14829,7 @@
                 <a:ea typeface="微软雅黑" pitchFamily="34" charset="-122"/>
                 <a:cs typeface="微软雅黑" pitchFamily="34" charset="-120"/>
               </a:rPr>
-              <a:t>帮扶管理信息系统 v1.12.19</a:t>
+              <a:t>帮扶管理信息系统 v1.12.20</a:t>
             </a:r>
             <a:endParaRPr lang="en-US" sz="1050" dirty="0"/>
           </a:p>
@@ -15455,7 +15455,7 @@
                 <a:ea typeface="微软雅黑" pitchFamily="34" charset="-122"/>
                 <a:cs typeface="微软雅黑" pitchFamily="34" charset="-120"/>
               </a:rPr>
-              <a:t>帮扶管理信息系统 v1.12.19</a:t>
+              <a:t>帮扶管理信息系统 v1.12.20</a:t>
             </a:r>
             <a:endParaRPr lang="en-US" sz="1050" dirty="0"/>
           </a:p>
@@ -16150,7 +16150,7 @@
                 <a:ea typeface="微软雅黑" pitchFamily="34" charset="-122"/>
                 <a:cs typeface="微软雅黑" pitchFamily="34" charset="-120"/>
               </a:rPr>
-              <a:t>帮扶管理信息系统 v1.12.19</a:t>
+              <a:t>帮扶管理信息系统 v1.12.20</a:t>
             </a:r>
             <a:endParaRPr lang="en-US" sz="1050" dirty="0"/>
           </a:p>
@@ -16849,7 +16849,7 @@
                 <a:ea typeface="微软雅黑" pitchFamily="34" charset="-122"/>
                 <a:cs typeface="微软雅黑" pitchFamily="34" charset="-120"/>
               </a:rPr>
-              <a:t>帮扶管理信息系统 v1.12.19</a:t>
+              <a:t>帮扶管理信息系统 v1.12.20</a:t>
             </a:r>
             <a:endParaRPr lang="en-US" sz="1050" dirty="0"/>
           </a:p>
@@ -17759,7 +17759,7 @@
                 <a:ea typeface="微软雅黑" pitchFamily="34" charset="-122"/>
                 <a:cs typeface="微软雅黑" pitchFamily="34" charset="-120"/>
               </a:rPr>
-              <a:t>帮扶管理信息系统 v1.12.19</a:t>
+              <a:t>帮扶管理信息系统 v1.12.20</a:t>
             </a:r>
             <a:endParaRPr lang="en-US" sz="1050" dirty="0"/>
           </a:p>
@@ -18973,7 +18973,7 @@
                 <a:ea typeface="微软雅黑" pitchFamily="34" charset="-122"/>
                 <a:cs typeface="微软雅黑" pitchFamily="34" charset="-120"/>
               </a:rPr>
-              <a:t>帮扶管理信息系统 v1.12.19</a:t>
+              <a:t>帮扶管理信息系统 v1.12.20</a:t>
             </a:r>
             <a:endParaRPr lang="en-US" sz="1050" dirty="0"/>
           </a:p>
@@ -20008,7 +20008,7 @@
                 <a:ea typeface="微软雅黑" pitchFamily="34" charset="-122"/>
                 <a:cs typeface="微软雅黑" pitchFamily="34" charset="-120"/>
               </a:rPr>
-              <a:t>帮扶管理信息系统 v1.12.19</a:t>
+              <a:t>帮扶管理信息系统 v1.12.20</a:t>
             </a:r>
             <a:endParaRPr lang="en-US" sz="1050" dirty="0"/>
           </a:p>
@@ -20857,7 +20857,7 @@
                 <a:ea typeface="微软雅黑" pitchFamily="34" charset="-122"/>
                 <a:cs typeface="微软雅黑" pitchFamily="34" charset="-120"/>
               </a:rPr>
-              <a:t>帮扶管理信息系统 v1.12.19</a:t>
+              <a:t>帮扶管理信息系统 v1.12.20</a:t>
             </a:r>
             <a:endParaRPr lang="en-US" sz="1050" dirty="0"/>
           </a:p>
@@ -21771,7 +21771,7 @@
                 <a:ea typeface="微软雅黑" pitchFamily="34" charset="-122"/>
                 <a:cs typeface="微软雅黑" pitchFamily="34" charset="-120"/>
               </a:rPr>
-              <a:t>帮扶管理信息系统 v1.12.19</a:t>
+              <a:t>帮扶管理信息系统 v1.12.20</a:t>
             </a:r>
             <a:endParaRPr lang="en-US" sz="1050" dirty="0"/>
           </a:p>
@@ -22931,7 +22931,7 @@
                 <a:ea typeface="微软雅黑" pitchFamily="34" charset="-122"/>
                 <a:cs typeface="微软雅黑" pitchFamily="34" charset="-120"/>
               </a:rPr>
-              <a:t>帮扶管理信息系统 v1.12.19</a:t>
+              <a:t>帮扶管理信息系统 v1.12.20</a:t>
             </a:r>
             <a:endParaRPr lang="en-US" sz="1050" dirty="0"/>
           </a:p>
@@ -23951,7 +23951,7 @@
                 <a:ea typeface="微软雅黑" pitchFamily="34" charset="-122"/>
                 <a:cs typeface="微软雅黑" pitchFamily="34" charset="-120"/>
               </a:rPr>
-              <a:t>帮扶管理信息系统 v1.12.19</a:t>
+              <a:t>帮扶管理信息系统 v1.12.20</a:t>
             </a:r>
             <a:endParaRPr lang="en-US" sz="1050" dirty="0"/>
           </a:p>
@@ -24008,7 +24008,7 @@
                 <a:ea typeface="微软雅黑" pitchFamily="34" charset="-122"/>
                 <a:cs typeface="微软雅黑" pitchFamily="34" charset="-120"/>
               </a:rPr>
-              <a:t>数据来源：2026-10-17 实测（v1.12.19）· 后端 13067 / 前端 6409 用例 · 覆盖率 100%（行+分支）</a:t>
+              <a:t>数据来源：2026-10-17 实测（v1.12.20）· 后端 13067 / 前端 6409 用例 · 覆盖率 100%（行+分支）</a:t>
             </a:r>
             <a:endParaRPr lang="en-US" sz="1050" dirty="0"/>
           </a:p>
@@ -24473,7 +24473,7 @@
                 <a:ea typeface="微软雅黑" pitchFamily="34" charset="-122"/>
                 <a:cs typeface="微软雅黑" pitchFamily="34" charset="-120"/>
               </a:rPr>
-              <a:t>帮扶管理信息系统 v1.12.19</a:t>
+              <a:t>帮扶管理信息系统 v1.12.20</a:t>
             </a:r>
             <a:endParaRPr lang="en-US" sz="1050" dirty="0"/>
           </a:p>
@@ -25166,7 +25166,7 @@
                 <a:ea typeface="微软雅黑" pitchFamily="34" charset="-122"/>
                 <a:cs typeface="微软雅黑" pitchFamily="34" charset="-120"/>
               </a:rPr>
-              <a:t>帮扶管理信息系统 v1.12.19</a:t>
+              <a:t>帮扶管理信息系统 v1.12.20</a:t>
             </a:r>
             <a:endParaRPr lang="en-US" sz="1050" dirty="0"/>
           </a:p>
@@ -25792,7 +25792,7 @@
                 <a:ea typeface="微软雅黑" pitchFamily="34" charset="-122"/>
                 <a:cs typeface="微软雅黑" pitchFamily="34" charset="-120"/>
               </a:rPr>
-              <a:t>帮扶管理信息系统 v1.12.19</a:t>
+              <a:t>帮扶管理信息系统 v1.12.20</a:t>
             </a:r>
             <a:endParaRPr lang="en-US" sz="1050" dirty="0"/>
           </a:p>
@@ -26743,7 +26743,7 @@
                 <a:ea typeface="微软雅黑" pitchFamily="34" charset="-122"/>
                 <a:cs typeface="微软雅黑" pitchFamily="34" charset="-120"/>
               </a:rPr>
-              <a:t>帮扶管理信息系统 v1.12.19</a:t>
+              <a:t>帮扶管理信息系统 v1.12.20</a:t>
             </a:r>
             <a:endParaRPr lang="en-US" sz="1050" dirty="0"/>
           </a:p>
@@ -27841,7 +27841,7 @@
                 <a:ea typeface="微软雅黑" pitchFamily="34" charset="-122"/>
                 <a:cs typeface="微软雅黑" pitchFamily="34" charset="-120"/>
               </a:rPr>
-              <a:t>帮扶管理信息系统 v1.12.19</a:t>
+              <a:t>帮扶管理信息系统 v1.12.20</a:t>
             </a:r>
             <a:endParaRPr lang="en-US" sz="1050" dirty="0"/>
           </a:p>
@@ -28488,7 +28488,7 @@
                 <a:ea typeface="微软雅黑" pitchFamily="34" charset="-122"/>
                 <a:cs typeface="微软雅黑" pitchFamily="34" charset="-120"/>
               </a:rPr>
-              <a:t>帮扶管理信息系统 v1.12.19</a:t>
+              <a:t>帮扶管理信息系统 v1.12.20</a:t>
             </a:r>
             <a:endParaRPr lang="en-US" sz="1050" dirty="0"/>
           </a:p>
@@ -29544,7 +29544,7 @@
                 <a:ea typeface="微软雅黑" pitchFamily="34" charset="-122"/>
                 <a:cs typeface="微软雅黑" pitchFamily="34" charset="-120"/>
               </a:rPr>
-              <a:t>帮扶管理信息系统 v1.12.19</a:t>
+              <a:t>帮扶管理信息系统 v1.12.20</a:t>
             </a:r>
             <a:endParaRPr lang="en-US" sz="1050" dirty="0"/>
           </a:p>
@@ -30123,7 +30123,7 @@
                 <a:ea typeface="微软雅黑" pitchFamily="34" charset="-122"/>
                 <a:cs typeface="微软雅黑" pitchFamily="34" charset="-120"/>
               </a:rPr>
-              <a:t>帮扶管理信息系统 v1.12.19</a:t>
+              <a:t>帮扶管理信息系统 v1.12.20</a:t>
             </a:r>
             <a:endParaRPr lang="en-US" sz="1050" dirty="0"/>
           </a:p>
@@ -31016,7 +31016,7 @@
                 <a:ea typeface="微软雅黑" pitchFamily="34" charset="-122"/>
                 <a:cs typeface="微软雅黑" pitchFamily="34" charset="-120"/>
               </a:rPr>
-              <a:t>帮扶管理信息系统 v1.12.19  ·  仓库：github.com/lzh745200/MRRS  ·  完整文档见 docs/ 目录</a:t>
+              <a:t>帮扶管理信息系统 v1.12.20  ·  仓库：github.com/lzh745200/MRRS  ·  完整文档见 docs/ 目录</a:t>
             </a:r>
             <a:endParaRPr lang="en-US" sz="1350" dirty="0"/>
           </a:p>
@@ -31277,7 +31277,7 @@
                 <a:ea typeface="微软雅黑" pitchFamily="34" charset="-122"/>
                 <a:cs typeface="微软雅黑" pitchFamily="34" charset="-120"/>
               </a:rPr>
-              <a:t>帮扶管理信息系统 v1.12.19</a:t>
+              <a:t>帮扶管理信息系统 v1.12.20</a:t>
             </a:r>
             <a:endParaRPr lang="en-US" sz="1050" dirty="0"/>
           </a:p>
@@ -32053,7 +32053,7 @@
                 <a:ea typeface="微软雅黑" pitchFamily="34" charset="-122"/>
                 <a:cs typeface="微软雅黑" pitchFamily="34" charset="-120"/>
               </a:rPr>
-              <a:t>帮扶管理信息系统 v1.12.19</a:t>
+              <a:t>帮扶管理信息系统 v1.12.20</a:t>
             </a:r>
             <a:endParaRPr lang="en-US" sz="1050" dirty="0"/>
           </a:p>
@@ -32777,7 +32777,7 @@
                 <a:ea typeface="微软雅黑" pitchFamily="34" charset="-122"/>
                 <a:cs typeface="微软雅黑" pitchFamily="34" charset="-120"/>
               </a:rPr>
-              <a:t>数据来源：2026-10-17 仓库实测（v1.12.19）—— 后端 13067 用例全绿 / 行+分支覆盖率 100%（branch=True 严格门禁）· 前端 6409 用例全绿 · flake8 0 · bandit 0 中高危 · vue-tsc 0 · eslint 0 警告</a:t>
+              <a:t>数据来源：2026-10-17 仓库实测（v1.12.20）—— 后端 13067 用例全绿 / 行+分支覆盖率 100%（branch=True 严格门禁）· 前端 6409 用例全绿 · flake8 0 · bandit 0 中高危 · vue-tsc 0 · eslint 0 警告</a:t>
             </a:r>
             <a:endParaRPr lang="en-US" sz="1000" dirty="0"/>
           </a:p>
@@ -33301,7 +33301,7 @@
                 <a:ea typeface="微软雅黑" pitchFamily="34" charset="-122"/>
                 <a:cs typeface="微软雅黑" pitchFamily="34" charset="-120"/>
               </a:rPr>
-              <a:t>帮扶管理信息系统 v1.12.19</a:t>
+              <a:t>帮扶管理信息系统 v1.12.20</a:t>
             </a:r>
             <a:endParaRPr lang="en-US" sz="1050" dirty="0"/>
           </a:p>
@@ -34413,7 +34413,7 @@
                 <a:ea typeface="微软雅黑" pitchFamily="34" charset="-122"/>
                 <a:cs typeface="微软雅黑" pitchFamily="34" charset="-120"/>
               </a:rPr>
-              <a:t>帮扶管理信息系统 v1.12.19</a:t>
+              <a:t>帮扶管理信息系统 v1.12.20</a:t>
             </a:r>
             <a:endParaRPr lang="en-US" sz="1050" dirty="0"/>
           </a:p>

</xml_diff>

<commit_message>
fix(release): v1.12.24 — W5-T5 解包口径收口 + 分支门禁确定性
## 前端 lint 门禁修复（CI PR Checks frontend-check 红）
- 收敛 50 处 `no-restricted-syntax`（手写 `.data.items` 解包）到唯一入口 `@/utils/unwrapList`，
  覆盖 40 个文件（列表/详情/仪表盘/导出等）；补齐 `unwrapList<T>` 泛型使 vue-tsc 严格模式 0 错误。
- 顺带修正 3 处「空数组 truthy 短路」语义缺陷：ChartRow（data.data 嵌套）、ConflictResolution
  （data.data 嵌套）、ContractManage（裸数组形态兜底）。
- 版本兜底同步：frontend/src/config/constants.ts SYSTEM_VERSION 随单源更新（修复 constants 测试 2 例）。

## 后端分支门禁确定性
- 新增 backend/tests/unit/test_branch_closure_r22.py（21 项）：覆盖 23 个历史错误/边界分支
  （help 片段边界、批量表白名单、cache None 哨兵、村附件扩展名、增量检测模型回退、管控包配置类型、
  数据包友好错误、加密包与备份恢复清理路径、相对 LOG_FILE、凭证无项目、预览 50 行截断、
  政策导入非 dict、注册认领竞争），使分支覆盖不依赖测试执行顺序/未提交测试。

## 版本与文档
- 版本 1.12.23 → 1.12.24（15 处单源同步）；CHANGELOG/README/PPT 口径同步。

## 验证
- 前端全量：316 文件 / 6,685 用例全通过，src/** 12 组 glob 四指标 100%；vue-tsc 0；eslint 0。
- 后端：CI backend-test 在上一提交全绿；本提交不改后端运行时代码（仅新增测试）。
</commit_message>
<xml_diff>
--- a/docs/帮扶管理信息系统介绍.pptx
+++ b/docs/帮扶管理信息系统介绍.pptx
@@ -4976,7 +4976,7 @@
                 <a:ea typeface="微软雅黑" pitchFamily="34" charset="-122"/>
                 <a:cs typeface="微软雅黑" pitchFamily="34" charset="-120"/>
               </a:rPr>
-              <a:t>V1.12.22  |  2026-10-17  |  FastAPI + Vue 3 + Electron + SQLite</a:t>
+              <a:t>V1.12.24  |  2026-10-17  |  FastAPI + Vue 3 + Electron + SQLite</a:t>
             </a:r>
             <a:endParaRPr lang="en-US" sz="1250" dirty="0"/>
           </a:p>
@@ -5196,7 +5196,7 @@
                 <a:ea typeface="微软雅黑" pitchFamily="34" charset="-122"/>
                 <a:cs typeface="微软雅黑" pitchFamily="34" charset="-120"/>
               </a:rPr>
-              <a:t>帮扶管理信息系统 v1.12.22</a:t>
+              <a:t>帮扶管理信息系统 v1.12.24</a:t>
             </a:r>
             <a:endParaRPr lang="en-US" sz="1050" dirty="0"/>
           </a:p>
@@ -5378,7 +5378,7 @@
                 <a:ea typeface="微软雅黑" pitchFamily="34" charset="-122"/>
                 <a:cs typeface="微软雅黑" pitchFamily="34" charset="-120"/>
               </a:rPr>
-              <a:t>315 个测试文件 · 6612 个用例</a:t>
+              <a:t>315 个测试文件 · 6685 个用例</a:t>
             </a:r>
             <a:endParaRPr lang="en-US" sz="1350" dirty="0"/>
           </a:p>
@@ -5822,7 +5822,7 @@
                 <a:ea typeface="微软雅黑" pitchFamily="34" charset="-122"/>
                 <a:cs typeface="微软雅黑" pitchFamily="34" charset="-120"/>
               </a:rPr>
-              <a:t>帮扶管理信息系统 v1.12.22</a:t>
+              <a:t>帮扶管理信息系统 v1.12.24</a:t>
             </a:r>
             <a:endParaRPr lang="en-US" sz="1050" dirty="0"/>
           </a:p>
@@ -6754,7 +6754,7 @@
                 <a:ea typeface="微软雅黑" pitchFamily="34" charset="-122"/>
                 <a:cs typeface="微软雅黑" pitchFamily="34" charset="-120"/>
               </a:rPr>
-              <a:t>帮扶管理信息系统 v1.12.22</a:t>
+              <a:t>帮扶管理信息系统 v1.12.24</a:t>
             </a:r>
             <a:endParaRPr lang="en-US" sz="1050" dirty="0"/>
           </a:p>
@@ -7380,7 +7380,7 @@
                 <a:ea typeface="微软雅黑" pitchFamily="34" charset="-122"/>
                 <a:cs typeface="微软雅黑" pitchFamily="34" charset="-120"/>
               </a:rPr>
-              <a:t>帮扶管理信息系统 v1.12.22</a:t>
+              <a:t>帮扶管理信息系统 v1.12.24</a:t>
             </a:r>
             <a:endParaRPr lang="en-US" sz="1050" dirty="0"/>
           </a:p>
@@ -8809,7 +8809,7 @@
                 <a:ea typeface="微软雅黑" pitchFamily="34" charset="-122"/>
                 <a:cs typeface="微软雅黑" pitchFamily="34" charset="-120"/>
               </a:rPr>
-              <a:t>帮扶管理信息系统 v1.12.22</a:t>
+              <a:t>帮扶管理信息系统 v1.12.24</a:t>
             </a:r>
             <a:endParaRPr lang="en-US" sz="1050" dirty="0"/>
           </a:p>
@@ -10006,7 +10006,7 @@
                 <a:ea typeface="微软雅黑" pitchFamily="34" charset="-122"/>
                 <a:cs typeface="微软雅黑" pitchFamily="34" charset="-120"/>
               </a:rPr>
-              <a:t>帮扶管理信息系统 v1.12.22</a:t>
+              <a:t>帮扶管理信息系统 v1.12.24</a:t>
             </a:r>
             <a:endParaRPr lang="en-US" sz="1050" dirty="0"/>
           </a:p>
@@ -10632,7 +10632,7 @@
                 <a:ea typeface="微软雅黑" pitchFamily="34" charset="-122"/>
                 <a:cs typeface="微软雅黑" pitchFamily="34" charset="-120"/>
               </a:rPr>
-              <a:t>帮扶管理信息系统 v1.12.22</a:t>
+              <a:t>帮扶管理信息系统 v1.12.24</a:t>
             </a:r>
             <a:endParaRPr lang="en-US" sz="1050" dirty="0"/>
           </a:p>
@@ -11496,7 +11496,7 @@
                 <a:ea typeface="微软雅黑" pitchFamily="34" charset="-122"/>
                 <a:cs typeface="微软雅黑" pitchFamily="34" charset="-120"/>
               </a:rPr>
-              <a:t>帮扶管理信息系统 v1.12.22</a:t>
+              <a:t>帮扶管理信息系统 v1.12.24</a:t>
             </a:r>
             <a:endParaRPr lang="en-US" sz="1050" dirty="0"/>
           </a:p>
@@ -12235,7 +12235,7 @@
                 <a:ea typeface="微软雅黑" pitchFamily="34" charset="-122"/>
                 <a:cs typeface="微软雅黑" pitchFamily="34" charset="-120"/>
               </a:rPr>
-              <a:t>帮扶管理信息系统 v1.12.22</a:t>
+              <a:t>帮扶管理信息系统 v1.12.24</a:t>
             </a:r>
             <a:endParaRPr lang="en-US" sz="1050" dirty="0"/>
           </a:p>
@@ -14460,7 +14460,7 @@
                 <a:ea typeface="微软雅黑" pitchFamily="34" charset="-122"/>
                 <a:cs typeface="微软雅黑" pitchFamily="34" charset="-120"/>
               </a:rPr>
-              <a:t>19,961 项自动化测试 · CI/CD · 依赖自检</a:t>
+              <a:t>20,190 项自动化测试 · CI/CD · 依赖自检</a:t>
             </a:r>
             <a:endParaRPr lang="en-US" sz="1200" dirty="0"/>
           </a:p>
@@ -14829,7 +14829,7 @@
                 <a:ea typeface="微软雅黑" pitchFamily="34" charset="-122"/>
                 <a:cs typeface="微软雅黑" pitchFamily="34" charset="-120"/>
               </a:rPr>
-              <a:t>帮扶管理信息系统 v1.12.22</a:t>
+              <a:t>帮扶管理信息系统 v1.12.24</a:t>
             </a:r>
             <a:endParaRPr lang="en-US" sz="1050" dirty="0"/>
           </a:p>
@@ -15455,7 +15455,7 @@
                 <a:ea typeface="微软雅黑" pitchFamily="34" charset="-122"/>
                 <a:cs typeface="微软雅黑" pitchFamily="34" charset="-120"/>
               </a:rPr>
-              <a:t>帮扶管理信息系统 v1.12.22</a:t>
+              <a:t>帮扶管理信息系统 v1.12.24</a:t>
             </a:r>
             <a:endParaRPr lang="en-US" sz="1050" dirty="0"/>
           </a:p>
@@ -16150,7 +16150,7 @@
                 <a:ea typeface="微软雅黑" pitchFamily="34" charset="-122"/>
                 <a:cs typeface="微软雅黑" pitchFamily="34" charset="-120"/>
               </a:rPr>
-              <a:t>帮扶管理信息系统 v1.12.22</a:t>
+              <a:t>帮扶管理信息系统 v1.12.24</a:t>
             </a:r>
             <a:endParaRPr lang="en-US" sz="1050" dirty="0"/>
           </a:p>
@@ -16849,7 +16849,7 @@
                 <a:ea typeface="微软雅黑" pitchFamily="34" charset="-122"/>
                 <a:cs typeface="微软雅黑" pitchFamily="34" charset="-120"/>
               </a:rPr>
-              <a:t>帮扶管理信息系统 v1.12.22</a:t>
+              <a:t>帮扶管理信息系统 v1.12.24</a:t>
             </a:r>
             <a:endParaRPr lang="en-US" sz="1050" dirty="0"/>
           </a:p>
@@ -17759,7 +17759,7 @@
                 <a:ea typeface="微软雅黑" pitchFamily="34" charset="-122"/>
                 <a:cs typeface="微软雅黑" pitchFamily="34" charset="-120"/>
               </a:rPr>
-              <a:t>帮扶管理信息系统 v1.12.22</a:t>
+              <a:t>帮扶管理信息系统 v1.12.24</a:t>
             </a:r>
             <a:endParaRPr lang="en-US" sz="1050" dirty="0"/>
           </a:p>
@@ -18973,7 +18973,7 @@
                 <a:ea typeface="微软雅黑" pitchFamily="34" charset="-122"/>
                 <a:cs typeface="微软雅黑" pitchFamily="34" charset="-120"/>
               </a:rPr>
-              <a:t>帮扶管理信息系统 v1.12.22</a:t>
+              <a:t>帮扶管理信息系统 v1.12.24</a:t>
             </a:r>
             <a:endParaRPr lang="en-US" sz="1050" dirty="0"/>
           </a:p>
@@ -20008,7 +20008,7 @@
                 <a:ea typeface="微软雅黑" pitchFamily="34" charset="-122"/>
                 <a:cs typeface="微软雅黑" pitchFamily="34" charset="-120"/>
               </a:rPr>
-              <a:t>帮扶管理信息系统 v1.12.22</a:t>
+              <a:t>帮扶管理信息系统 v1.12.24</a:t>
             </a:r>
             <a:endParaRPr lang="en-US" sz="1050" dirty="0"/>
           </a:p>
@@ -20857,7 +20857,7 @@
                 <a:ea typeface="微软雅黑" pitchFamily="34" charset="-122"/>
                 <a:cs typeface="微软雅黑" pitchFamily="34" charset="-120"/>
               </a:rPr>
-              <a:t>帮扶管理信息系统 v1.12.22</a:t>
+              <a:t>帮扶管理信息系统 v1.12.24</a:t>
             </a:r>
             <a:endParaRPr lang="en-US" sz="1050" dirty="0"/>
           </a:p>
@@ -21771,7 +21771,7 @@
                 <a:ea typeface="微软雅黑" pitchFamily="34" charset="-122"/>
                 <a:cs typeface="微软雅黑" pitchFamily="34" charset="-120"/>
               </a:rPr>
-              <a:t>帮扶管理信息系统 v1.12.22</a:t>
+              <a:t>帮扶管理信息系统 v1.12.24</a:t>
             </a:r>
             <a:endParaRPr lang="en-US" sz="1050" dirty="0"/>
           </a:p>
@@ -22931,7 +22931,7 @@
                 <a:ea typeface="微软雅黑" pitchFamily="34" charset="-122"/>
                 <a:cs typeface="微软雅黑" pitchFamily="34" charset="-120"/>
               </a:rPr>
-              <a:t>帮扶管理信息系统 v1.12.22</a:t>
+              <a:t>帮扶管理信息系统 v1.12.24</a:t>
             </a:r>
             <a:endParaRPr lang="en-US" sz="1050" dirty="0"/>
           </a:p>
@@ -23585,7 +23585,7 @@
                 <a:ea typeface="微软雅黑" pitchFamily="34" charset="-122"/>
                 <a:cs typeface="微软雅黑" pitchFamily="34" charset="-120"/>
               </a:rPr>
-              <a:t>19,961 项自动化测试（后端 13349 + 前端 6612）</a:t>
+              <a:t>20,190 项自动化测试（后端 13349 + 前端 6612）</a:t>
             </a:r>
             <a:endParaRPr lang="en-US" sz="1400" dirty="0"/>
           </a:p>
@@ -23951,7 +23951,7 @@
                 <a:ea typeface="微软雅黑" pitchFamily="34" charset="-122"/>
                 <a:cs typeface="微软雅黑" pitchFamily="34" charset="-120"/>
               </a:rPr>
-              <a:t>帮扶管理信息系统 v1.12.22</a:t>
+              <a:t>帮扶管理信息系统 v1.12.24</a:t>
             </a:r>
             <a:endParaRPr lang="en-US" sz="1050" dirty="0"/>
           </a:p>
@@ -24008,7 +24008,7 @@
                 <a:ea typeface="微软雅黑" pitchFamily="34" charset="-122"/>
                 <a:cs typeface="微软雅黑" pitchFamily="34" charset="-120"/>
               </a:rPr>
-              <a:t>数据来源：2026-10-17 实测（v1.12.22）· 后端 13349 / 前端 6612 用例 · 覆盖率 100%（行+分支）</a:t>
+              <a:t>数据来源：2026-10-17 实测（v1.12.24）· 后端 13349 / 前端 6685 用例 · 覆盖率 100%（行+分支）</a:t>
             </a:r>
             <a:endParaRPr lang="en-US" sz="1050" dirty="0"/>
           </a:p>
@@ -24473,7 +24473,7 @@
                 <a:ea typeface="微软雅黑" pitchFamily="34" charset="-122"/>
                 <a:cs typeface="微软雅黑" pitchFamily="34" charset="-120"/>
               </a:rPr>
-              <a:t>帮扶管理信息系统 v1.12.22</a:t>
+              <a:t>帮扶管理信息系统 v1.12.24</a:t>
             </a:r>
             <a:endParaRPr lang="en-US" sz="1050" dirty="0"/>
           </a:p>
@@ -25166,7 +25166,7 @@
                 <a:ea typeface="微软雅黑" pitchFamily="34" charset="-122"/>
                 <a:cs typeface="微软雅黑" pitchFamily="34" charset="-120"/>
               </a:rPr>
-              <a:t>帮扶管理信息系统 v1.12.22</a:t>
+              <a:t>帮扶管理信息系统 v1.12.24</a:t>
             </a:r>
             <a:endParaRPr lang="en-US" sz="1050" dirty="0"/>
           </a:p>
@@ -25792,7 +25792,7 @@
                 <a:ea typeface="微软雅黑" pitchFamily="34" charset="-122"/>
                 <a:cs typeface="微软雅黑" pitchFamily="34" charset="-120"/>
               </a:rPr>
-              <a:t>帮扶管理信息系统 v1.12.22</a:t>
+              <a:t>帮扶管理信息系统 v1.12.24</a:t>
             </a:r>
             <a:endParaRPr lang="en-US" sz="1050" dirty="0"/>
           </a:p>
@@ -26743,7 +26743,7 @@
                 <a:ea typeface="微软雅黑" pitchFamily="34" charset="-122"/>
                 <a:cs typeface="微软雅黑" pitchFamily="34" charset="-120"/>
               </a:rPr>
-              <a:t>帮扶管理信息系统 v1.12.22</a:t>
+              <a:t>帮扶管理信息系统 v1.12.24</a:t>
             </a:r>
             <a:endParaRPr lang="en-US" sz="1050" dirty="0"/>
           </a:p>
@@ -27841,7 +27841,7 @@
                 <a:ea typeface="微软雅黑" pitchFamily="34" charset="-122"/>
                 <a:cs typeface="微软雅黑" pitchFamily="34" charset="-120"/>
               </a:rPr>
-              <a:t>帮扶管理信息系统 v1.12.22</a:t>
+              <a:t>帮扶管理信息系统 v1.12.24</a:t>
             </a:r>
             <a:endParaRPr lang="en-US" sz="1050" dirty="0"/>
           </a:p>
@@ -28488,7 +28488,7 @@
                 <a:ea typeface="微软雅黑" pitchFamily="34" charset="-122"/>
                 <a:cs typeface="微软雅黑" pitchFamily="34" charset="-120"/>
               </a:rPr>
-              <a:t>帮扶管理信息系统 v1.12.22</a:t>
+              <a:t>帮扶管理信息系统 v1.12.24</a:t>
             </a:r>
             <a:endParaRPr lang="en-US" sz="1050" dirty="0"/>
           </a:p>
@@ -29544,7 +29544,7 @@
                 <a:ea typeface="微软雅黑" pitchFamily="34" charset="-122"/>
                 <a:cs typeface="微软雅黑" pitchFamily="34" charset="-120"/>
               </a:rPr>
-              <a:t>帮扶管理信息系统 v1.12.22</a:t>
+              <a:t>帮扶管理信息系统 v1.12.24</a:t>
             </a:r>
             <a:endParaRPr lang="en-US" sz="1050" dirty="0"/>
           </a:p>
@@ -30123,7 +30123,7 @@
                 <a:ea typeface="微软雅黑" pitchFamily="34" charset="-122"/>
                 <a:cs typeface="微软雅黑" pitchFamily="34" charset="-120"/>
               </a:rPr>
-              <a:t>帮扶管理信息系统 v1.12.22</a:t>
+              <a:t>帮扶管理信息系统 v1.12.24</a:t>
             </a:r>
             <a:endParaRPr lang="en-US" sz="1050" dirty="0"/>
           </a:p>
@@ -31016,7 +31016,7 @@
                 <a:ea typeface="微软雅黑" pitchFamily="34" charset="-122"/>
                 <a:cs typeface="微软雅黑" pitchFamily="34" charset="-120"/>
               </a:rPr>
-              <a:t>帮扶管理信息系统 v1.12.22  ·  仓库：github.com/lzh745200/MRRS  ·  完整文档见 docs/ 目录</a:t>
+              <a:t>帮扶管理信息系统 v1.12.24  ·  仓库：github.com/lzh745200/MRRS  ·  完整文档见 docs/ 目录</a:t>
             </a:r>
             <a:endParaRPr lang="en-US" sz="1350" dirty="0"/>
           </a:p>
@@ -31277,7 +31277,7 @@
                 <a:ea typeface="微软雅黑" pitchFamily="34" charset="-122"/>
                 <a:cs typeface="微软雅黑" pitchFamily="34" charset="-120"/>
               </a:rPr>
-              <a:t>帮扶管理信息系统 v1.12.22</a:t>
+              <a:t>帮扶管理信息系统 v1.12.24</a:t>
             </a:r>
             <a:endParaRPr lang="en-US" sz="1050" dirty="0"/>
           </a:p>
@@ -32053,7 +32053,7 @@
                 <a:ea typeface="微软雅黑" pitchFamily="34" charset="-122"/>
                 <a:cs typeface="微软雅黑" pitchFamily="34" charset="-120"/>
               </a:rPr>
-              <a:t>帮扶管理信息系统 v1.12.22</a:t>
+              <a:t>帮扶管理信息系统 v1.12.24</a:t>
             </a:r>
             <a:endParaRPr lang="en-US" sz="1050" dirty="0"/>
           </a:p>
@@ -32777,7 +32777,7 @@
                 <a:ea typeface="微软雅黑" pitchFamily="34" charset="-122"/>
                 <a:cs typeface="微软雅黑" pitchFamily="34" charset="-120"/>
               </a:rPr>
-              <a:t>数据来源：2026-10-17 仓库实测（v1.12.22）—— 后端 13349 用例全绿 / 行+分支覆盖率 100%（branch=True 严格门禁）· 前端 6612 用例全绿 · flake8 0 · bandit 0 中高危 · vue-tsc 0 · eslint 0 警告</a:t>
+              <a:t>数据来源：2026-10-17 仓库实测（v1.12.24）—— 后端 13505 用例全绿 / 行+分支覆盖率 100%（branch=True 严格门禁）· 前端 6685 用例全绿 · flake8 0 · bandit 0 中高危 · vue-tsc 0 · eslint 0 警告</a:t>
             </a:r>
             <a:endParaRPr lang="en-US" sz="1000" dirty="0"/>
           </a:p>
@@ -33301,7 +33301,7 @@
                 <a:ea typeface="微软雅黑" pitchFamily="34" charset="-122"/>
                 <a:cs typeface="微软雅黑" pitchFamily="34" charset="-120"/>
               </a:rPr>
-              <a:t>帮扶管理信息系统 v1.12.22</a:t>
+              <a:t>帮扶管理信息系统 v1.12.24</a:t>
             </a:r>
             <a:endParaRPr lang="en-US" sz="1050" dirty="0"/>
           </a:p>
@@ -34413,7 +34413,7 @@
                 <a:ea typeface="微软雅黑" pitchFamily="34" charset="-122"/>
                 <a:cs typeface="微软雅黑" pitchFamily="34" charset="-120"/>
               </a:rPr>
-              <a:t>帮扶管理信息系统 v1.12.22</a:t>
+              <a:t>帮扶管理信息系统 v1.12.24</a:t>
             </a:r>
             <a:endParaRPr lang="en-US" sz="1050" dirty="0"/>
           </a:p>

</xml_diff>